<commit_message>
Link the demo video (youtu.be/GG3v7lQ212M) in the README, the checklist and the deck
Co-Authored-By: Claude Opus 5.5 <noreply@anthropic.com>
</commit_message>
<xml_diff>
--- a/web/deck/SUNO_build_deck.pptx
+++ b/web/deck/SUNO_build_deck.pptx
@@ -122,13 +122,13 @@
   <p:extLst>
     <p:ext uri="{521415D9-36F7-43E2-AB2F-B90AF26B5E84}">
       <p14:sectionLst xmlns:p14="http://schemas.microsoft.com/office/powerpoint/2010/main">
-        <p14:section name="SUNO" id="{ee8ef65d-5297-5727-231f-8c802a395b41}">
+        <p14:section name="SUNO" id="{9bbc9130-813c-e902-cc28-d6f8a0d8ccc4}">
           <p14:sldIdLst>
             <p14:sldId id="256"/>
             <p14:sldId id="257"/>
           </p14:sldIdLst>
         </p14:section>
-        <p14:section name="Effective AI use and technical strength" id="{aa19abeb-f5d2-7f20-f529-a828c583dd1c}">
+        <p14:section name="Effective AI use and technical strength" id="{2e4f4943-8b81-44ff-c715-625264acdac4}">
           <p14:sldIdLst>
             <p14:sldId id="258"/>
             <p14:sldId id="259"/>
@@ -139,21 +139,21 @@
             <p14:sldId id="264"/>
           </p14:sldIdLst>
         </p14:section>
-        <p14:section name="User inputs and testing" id="{89188326-0547-9406-835c-7fb3f38bdc12}">
+        <p14:section name="User inputs and testing" id="{763a3b88-d8ca-a66d-dffe-f732376d0eb9}">
           <p14:sldIdLst>
             <p14:sldId id="265"/>
             <p14:sldId id="266"/>
             <p14:sldId id="267"/>
           </p14:sldIdLst>
         </p14:section>
-        <p14:section name="Future roadmap" id="{64ad35af-a905-df5d-0df6-d0910d22c45c}">
+        <p14:section name="Future roadmap" id="{b07612fb-b3e4-38a0-15bd-bb5eec7f3dfc}">
           <p14:sldIdLst>
             <p14:sldId id="268"/>
             <p14:sldId id="269"/>
             <p14:sldId id="270"/>
           </p14:sldIdLst>
         </p14:section>
-        <p14:section name="Try it" id="{f8a09356-7aaf-e5ec-c6c1-b173e62e963d}">
+        <p14:section name="Try it" id="{85c87f70-1fcf-380a-c815-f503dd36cc8f}">
           <p14:sldIdLst>
             <p14:sldId id="271"/>
           </p14:sldIdLst>
@@ -3554,7 +3554,7 @@
                   <a:srgbClr val="C9CFEE"/>
                 </a:solidFill>
               </a:rPr>
-              <a:t>Live: suno-8qoh.onrender.com · code SUNO-DEMO</a:t>
+              <a:t>Live: suno-8qoh.onrender.com · code SUNO-DEMO · video: youtu.be/GG3v7lQ212M</a:t>
             </a:r>
             <a:endParaRPr lang="en-US" sz="1200" dirty="0"/>
           </a:p>
@@ -8683,6 +8683,37 @@
                 </a:solidFill>
               </a:rPr>
               <a:t>Turn the network off, record a note, turn it back on: it sends itself</a:t>
+            </a:r>
+            <a:endParaRPr lang="en-US" sz="1400" dirty="0"/>
+          </a:p>
+          <a:p>
+            <a:pPr indent="0" marL="0">
+              <a:spcAft>
+                <a:spcPts val="1000"/>
+              </a:spcAft>
+              <a:buNone/>
+            </a:pPr>
+            <a:r>
+              <a:rPr lang="en-US" sz="1400" b="1" dirty="0">
+                <a:solidFill>
+                  <a:srgbClr val="FFFFFF"/>
+                </a:solidFill>
+              </a:rPr>
+              <a:t>Demo video  </a:t>
+            </a:r>
+            <a:pPr indent="0" marL="0">
+              <a:spcAft>
+                <a:spcPts val="1000"/>
+              </a:spcAft>
+              <a:buNone/>
+            </a:pPr>
+            <a:r>
+              <a:rPr lang="en-US" sz="1400" dirty="0">
+                <a:solidFill>
+                  <a:srgbClr val="C9CFEE"/>
+                </a:solidFill>
+              </a:rPr>
+              <a:t>youtu.be/GG3v7lQ212M (3 minutes)</a:t>
             </a:r>
             <a:endParaRPr lang="en-US" sz="1400" dirty="0"/>
           </a:p>

</xml_diff>